<commit_message>
docs: align pitch and docs with implemented review behavior
</commit_message>
<xml_diff>
--- a/pitch/PitchPractice-Pitch.pptx
+++ b/pitch/PitchPractice-Pitch.pptx
@@ -120,23 +120,23 @@
   <p:extLst>
     <p:ext uri="{521415D9-36F7-43E2-AB2F-B90AF26B5E84}">
       <p14:sectionLst xmlns:p14="http://schemas.microsoft.com/office/powerpoint/2010/main">
-        <p14:section name="Auftakt" id="{7b9270ef-0fe5-4ae2-4d9f-d8a4bf3602cb}">
+        <p14:section name="Auftakt" id="{7b05788e-6e65-e7fe-f867-2b0357919c6b}">
           <p14:sldIdLst>
             <p14:sldId id="256"/>
           </p14:sldIdLst>
         </p14:section>
-        <p14:section name="Problem &amp; Lösung" id="{bec2090a-157e-d358-acde-c6810d527406}">
+        <p14:section name="Problem &amp; Lösung" id="{f6f30cc2-e2f8-435b-aa42-5841c42bcab4}">
           <p14:sldIdLst>
             <p14:sldId id="257"/>
             <p14:sldId id="258"/>
           </p14:sldIdLst>
         </p14:section>
-        <p14:section name="Demo" id="{067a49aa-efed-17b1-b9fb-1034b5f11aa7}">
+        <p14:section name="Demo" id="{c558c2c7-fd01-a56d-f16a-cb574b9e3da6}">
           <p14:sldIdLst>
             <p14:sldId id="259"/>
           </p14:sldIdLst>
         </p14:section>
-        <p14:section name="Features" id="{16eb5510-6d36-4e8b-efdb-62e0b1f617a6}">
+        <p14:section name="Features" id="{e7e10c4c-15f5-c3b2-f9de-b5c74908e65c}">
           <p14:sldIdLst>
             <p14:sldId id="260"/>
             <p14:sldId id="261"/>
@@ -145,14 +145,14 @@
             <p14:sldId id="264"/>
           </p14:sldIdLst>
         </p14:section>
-        <p14:section name="Technik &amp; Zahlen" id="{5dd80ea8-77aa-c439-2bc4-0a7c35950dbe}">
+        <p14:section name="Technik &amp; Zahlen" id="{b9f59b67-00b4-62df-cfdf-1e76ed9da422}">
           <p14:sldIdLst>
             <p14:sldId id="265"/>
             <p14:sldId id="266"/>
             <p14:sldId id="267"/>
           </p14:sldIdLst>
         </p14:section>
-        <p14:section name="Reflection &amp; Abschluss" id="{82dac9e6-0183-eb9b-39f7-6efd7fdf0b27}">
+        <p14:section name="Reflection &amp; Abschluss" id="{5293656e-721a-efd9-0f01-8af7581983d9}">
           <p14:sldIdLst>
             <p14:sldId id="268"/>
             <p14:sldId id="269"/>
@@ -650,7 +650,7 @@
           <a:p>
             <a:r>
               <a:rPr lang="en-US" dirty="0"/>
-              <a:t>Technisch: Next.js vorne, FastAPI mit Celery und Redis hinten, Postgres mit pgvector, SeaweedFS als S3-Speicher. Der lokale Stack deckt Pose, VAD, Whisper und Embeddings ab; Cloud-Dienste wie Gemini, Deepgram oder ElevenLabs sind nur mit Einwilligung zugeschaltet. Der ganze Stack startet mit einem einzigen Compose-Befehl.</a:t>
+              <a:t>Technisch: Next.js vorne, FastAPI mit Celery und Redis hinten, Postgres mit pgvector, SeaweedFS als S3-Speicher. Der lokale Stack deckt Pose, VAD, Whisper und Embeddings ab; Cloud-Dienste wie Gemini, Deepgram oder ElevenLabs sind nur mit Einwilligung zugeschaltet. Ohne Cloud-Schlüssel bleiben Audio-, Pose- und Signalanalyse lokal; Quellencheck und Frage-Agent sind dann nicht verfügbar. Der ganze Stack startet mit einem einzigen Compose-Befehl.</a:t>
             </a:r>
             <a:endParaRPr lang="en-US" dirty="0"/>
           </a:p>
@@ -738,7 +738,7 @@
           <a:p>
             <a:r>
               <a:rPr lang="en-US" dirty="0"/>
-              <a:t>Datenschutz war für uns ein Feature, kein Anhängsel. Das Video verlässt den Client nie, das Original-Audio wird nach der Analyse gelöscht — auch bei Fehlern —, Pose-Frames gehen zu keinem Anbieter. Heuristiken kennzeichnen wir offen als unvalidiert, und es gibt keine Scores, keine Noten und keine Emotionsanalyse.</a:t>
+              <a:t>Datenschutz war für uns ein Feature, kein Anhängsel. Das Video verlässt den Client nie, das Original-Audio wird nach der Analyse gelöscht — auch bei Fehlern —, Pose-Frames gehen zu keinem Anbieter. Heuristiken kennzeichnen wir offen als unvalidiert. Die Auswertung zeigt evidenzbasierte Prototyp-Scores, aber keine Noten und keine Emotionsanalyse.</a:t>
             </a:r>
             <a:endParaRPr lang="en-US" dirty="0"/>
           </a:p>
@@ -1002,7 +1002,7 @@
           <a:p>
             <a:r>
               <a:rPr lang="en-US" dirty="0"/>
-              <a:t>Zum Schluss: Übe den Vortrag, nicht die Folien. Der Prototyp läuft lokal auf localhost 3000, ohne Login — wir laden herzlich zum Produktreview ein. Danke.</a:t>
+              <a:t>Zum Schluss: Übe den Vortrag, nicht die Folien. Der Prototyp läuft lokal auf localhost 3000, ohne Login; Quellencheck und Fragen nutzen optional Gemini. Wir laden herzlich zum Produktreview ein. Danke.</a:t>
             </a:r>
             <a:endParaRPr lang="en-US" dirty="0"/>
           </a:p>
@@ -1442,7 +1442,7 @@
           <a:p>
             <a:r>
               <a:rPr lang="en-US" dirty="0"/>
-              <a:t>Die Transkription läuft lokal mit faster-whisper, mit Wort-Timestamps; das Audio bleibt auf dem Gerät. Der Fact-Check läuft in vier Schritten: Aussagen extrahieren, Quellen per Hybrid-Suche durchsuchen, Urteil mit wörtlichem Zitat — und der Code prüft per String-Match, dass das Zitat wirklich in der Quelle steht. Und wichtig: „Nicht gefunden“ ist nicht „falsch“.</a:t>
+              <a:t>Die Transkription läuft lokal mit faster-whisper, mit Wort-Timestamps. Das Audio verlässt den Browser nur zum lokalen Server und wird nach der Analyse gelöscht. Der Fact-Check läuft in vier Schritten: Aussagen extrahieren, Quellen per Hybrid-Suche durchsuchen, Urteil mit wörtlichem Zitat — und der Code prüft per String-Match, dass das Zitat wirklich in der Quelle steht. Und wichtig: „Nicht gefunden“ ist nicht „falsch“.</a:t>
             </a:r>
             <a:endParaRPr lang="en-US" dirty="0"/>
           </a:p>
@@ -1618,7 +1618,7 @@
           <a:p>
             <a:r>
               <a:rPr lang="en-US" dirty="0"/>
-              <a:t>Das Herzstück für den Wert in unter drei Minuten: eine gemeinsame Timeline. Ein Klick auf einen Marker springt per Peak-Zeitstempel zur Stelle im lokalen Video, plus minus zwei Sekunden. Es gibt bewusst keinen serverseitigen Clip — das Video bleibt beim Nutzer.</a:t>
+              <a:t>Das Herzstück für den Wert in unter drei Minuten: eine gemeinsame Timeline. Ein Klick auf einen Marker springt per Peak-Zeitstempel zur Stelle im lokalen Video, plus minus zwei Sekunden. Es gibt bewusst keinen serverseitigen Clip — das Video bleibt beim Nutzer. Dazu kommen evidenzbasierte Kriterien-Scores; Formel und Datenabdeckung stehen direkt im UI. Optional zeigt der Fortschritt eine Messreihe über mehrere Takes, ohne Gesamtscore.</a:t>
             </a:r>
             <a:endParaRPr lang="en-US" dirty="0"/>
           </a:p>
@@ -1706,7 +1706,7 @@
           <a:p>
             <a:r>
               <a:rPr lang="en-US" dirty="0"/>
-              <a:t>Nach dem Vortrag übernimmt der Frage-Agent. Er fragt gezielt nach Widersprüchen und Lücken aus dem Fact-Check, Antworten können getippt oder gesprochen werden, und jede Antwort wird mit Zitat-Prüfung gegen die Quellen verglichen. Zwei Rollen sind wählbar: neugieriges Erstsemester oder kritischer Professor. Punkte und Noten gibt es bewusst keine.</a:t>
+              <a:t>Nach dem Vortrag übernimmt der Frage-Agent. Er fragt gezielt nach Widersprüchen und Lücken aus dem Fact-Check, Antworten können getippt oder gesprochen werden, und jede Antwort wird mit Zitat-Prüfung gegen die Quellen verglichen. Zwei Rollen sind wählbar: neugieriges Erstsemester oder kritischer Professor. Die Auswertung nach der getippten Runde ist ein transparenter Prototyp-Score aus gemessenen Urteilen, keine Note.</a:t>
             </a:r>
             <a:endParaRPr lang="en-US" dirty="0"/>
           </a:p>
@@ -2297,7 +2297,7 @@
       </p:sp>
       <p:pic>
         <p:nvPicPr>
-          <p:cNvPr id="3" name="Image 0" descr="/home/patrice/hackathon_fulda/hackathon-fulda/frontend/public/brand/418-pitch-practice.png">    </p:cNvPr>
+          <p:cNvPr id="3" name="Image 0" descr="C:\Users\Johannes\miniprojects\hackatron\frontend\public\brand\418-pitch-practice.png">    </p:cNvPr>
           <p:cNvPicPr>
             <a:picLocks noChangeAspect="1"/>
           </p:cNvPicPr>
@@ -2948,7 +2948,7 @@
                 <a:ea typeface="Open Sans" pitchFamily="34" charset="-122"/>
                 <a:cs typeface="Open Sans" pitchFamily="34" charset="-120"/>
               </a:rPr>
-              <a:t>Ohne Schlüssel bleibt alles auf dem lokalen Pfad</a:t>
+              <a:t>Ohne Cloud-Schlüssel entfallen Quellencheck und Frage-Agent</a:t>
             </a:r>
             <a:endParaRPr lang="en-US" sz="1300" dirty="0"/>
           </a:p>
@@ -3791,7 +3791,7 @@
                 <a:ea typeface="Open Sans" pitchFamily="34" charset="-122"/>
                 <a:cs typeface="Open Sans" pitchFamily="34" charset="-120"/>
               </a:rPr>
-              <a:t>Nur synthetische Demo-Daten</a:t>
+              <a:t>Synthetische Demo-Daten</a:t>
             </a:r>
             <a:endParaRPr lang="en-US" sz="1350" dirty="0"/>
           </a:p>
@@ -3830,7 +3830,7 @@
                 <a:ea typeface="Open Sans" pitchFamily="34" charset="-122"/>
                 <a:cs typeface="Open Sans" pitchFamily="34" charset="-120"/>
               </a:rPr>
-              <a:t>keine echten personenbezogenen Daten</a:t>
+              <a:t>Live-Aufnahmen nur mit Einwilligung</a:t>
             </a:r>
             <a:endParaRPr lang="en-US" sz="1200" dirty="0"/>
           </a:p>
@@ -4013,7 +4013,7 @@
                 <a:ea typeface="Open Sans" pitchFamily="34" charset="-122"/>
                 <a:cs typeface="Open Sans" pitchFamily="34" charset="-120"/>
               </a:rPr>
-              <a:t>Keine Scores, keine Noten, keine Emotionsanalyse — Feedback statt Benotung.</a:t>
+              <a:t>Evidenzbasierte Prototyp-Scores, keine Noten, keine Emotionsanalyse.</a:t>
             </a:r>
             <a:endParaRPr lang="en-US" sz="1600" dirty="0"/>
           </a:p>
@@ -4679,7 +4679,7 @@
                 <a:ea typeface="Open Sans" pitchFamily="34" charset="-122"/>
                 <a:cs typeface="Open Sans" pitchFamily="34" charset="-120"/>
               </a:rPr>
-              <a:t>33</a:t>
+              <a:t>44</a:t>
             </a:r>
             <a:endParaRPr lang="en-US" sz="3000" dirty="0"/>
           </a:p>
@@ -4779,7 +4779,7 @@
                 <a:ea typeface="Open Sans" pitchFamily="34" charset="-122"/>
                 <a:cs typeface="Open Sans" pitchFamily="34" charset="-120"/>
               </a:rPr>
-              <a:t>281</a:t>
+              <a:t>333</a:t>
             </a:r>
             <a:endParaRPr lang="en-US" sz="3000" dirty="0"/>
           </a:p>
@@ -4879,7 +4879,7 @@
                 <a:ea typeface="Open Sans" pitchFamily="34" charset="-122"/>
                 <a:cs typeface="Open Sans" pitchFamily="34" charset="-120"/>
               </a:rPr>
-              <a:t>232</a:t>
+              <a:t>261</a:t>
             </a:r>
             <a:endParaRPr lang="en-US" sz="3000" dirty="0"/>
           </a:p>
@@ -5529,7 +5529,7 @@
       </p:sp>
       <p:pic>
         <p:nvPicPr>
-          <p:cNvPr id="3" name="Image 0" descr="/home/patrice/hackathon_fulda/hackathon-fulda/frontend/public/brand/418-pitch-practice.png">    </p:cNvPr>
+          <p:cNvPr id="3" name="Image 0" descr="C:\Users\Johannes\miniprojects\hackatron\frontend\public\brand\418-pitch-practice.png">    </p:cNvPr>
           <p:cNvPicPr>
             <a:picLocks noChangeAspect="1"/>
           </p:cNvPicPr>
@@ -5623,7 +5623,7 @@
                 <a:ea typeface="Open Sans" pitchFamily="34" charset="-122"/>
                 <a:cs typeface="Open Sans" pitchFamily="34" charset="-120"/>
               </a:rPr>
-              <a:t>Prototyp läuft lokal: localhost:3000 — kein Login, keine Cloud-Pflicht.</a:t>
+              <a:t>Prototyp läuft lokal: localhost:3000 — kein Login; Cloud nur für Quellencheck und Fragen.</a:t>
             </a:r>
             <a:endParaRPr lang="en-US" sz="1800" dirty="0"/>
           </a:p>
@@ -7241,7 +7241,7 @@
                 <a:ea typeface="Open Sans" pitchFamily="34" charset="-122"/>
                 <a:cs typeface="Open Sans" pitchFamily="34" charset="-120"/>
               </a:rPr>
-              <a:t>Haltung, Stimme, Transkript und Fact-Check laufen automatisch</a:t>
+              <a:t>Haltung, Stimme und Transkript laufen automatisch; Fact-Check auf Klick</a:t>
             </a:r>
             <a:endParaRPr lang="en-US" sz="1250" dirty="0"/>
           </a:p>
@@ -8375,7 +8375,7 @@
                 <a:ea typeface="Open Sans" pitchFamily="34" charset="-122"/>
                 <a:cs typeface="Open Sans" pitchFamily="34" charset="-120"/>
               </a:rPr>
-              <a:t>Lokales faster-whisper: Deutsch, Wort-Timestamps — das Audio bleibt auf dem Gerät.</a:t>
+              <a:t>Lokales faster-whisper: Deutsch, Wort-Timestamps — das Audio wird nach der Analyse gelöscht.</a:t>
             </a:r>
             <a:endParaRPr lang="en-US" sz="1350" dirty="0"/>
           </a:p>
@@ -10519,6 +10519,45 @@
       </p:sp>
       <p:sp>
         <p:nvSpPr>
+          <p:cNvPr id="23" name="Text 18"/>
+          <p:cNvSpPr txBox="1"/>
+          <p:nvPr/>
+        </p:nvSpPr>
+        <p:spPr>
+          <a:xfrm>
+            <a:off x="566928" y="5715000"/>
+            <a:ext cx="11064240" cy="347472"/>
+          </a:xfrm>
+          <a:prstGeom prst="rect">
+            <a:avLst/>
+          </a:prstGeom>
+          <a:noFill/>
+          <a:ln/>
+        </p:spPr>
+        <p:txBody>
+          <a:bodyPr wrap="square" lIns="0" tIns="0" rIns="0" bIns="0" rtlCol="0" anchor="ctr"/>
+          <a:lstStyle/>
+          <a:p>
+            <a:pPr algn="ctr" indent="0" marL="0">
+              <a:buNone/>
+            </a:pPr>
+            <a:r>
+              <a:rPr lang="en-US" sz="1150" dirty="0">
+                <a:solidFill>
+                  <a:srgbClr val="6B6577"/>
+                </a:solidFill>
+                <a:latin typeface="Open Sans" pitchFamily="34" charset="0"/>
+                <a:ea typeface="Open Sans" pitchFamily="34" charset="-122"/>
+                <a:cs typeface="Open Sans" pitchFamily="34" charset="-120"/>
+              </a:rPr>
+              <a:t>Dazu: evidenzbasierte Kriterien-Scores, Formel und Abdeckung sichtbar. Optional Fortschritt über mehrere Takes — Messreihe mit Lücken, kein Gesamtscore.</a:t>
+            </a:r>
+            <a:endParaRPr lang="en-US" sz="1150" dirty="0"/>
+          </a:p>
+        </p:txBody>
+      </p:sp>
+      <p:sp>
+        <p:nvSpPr>
           <p:cNvPr id="25" name="Slide Number Placeholder 0"/>
           <p:cNvSpPr>
             <a:spLocks noGrp="1"/>
@@ -11181,7 +11220,7 @@
                 <a:ea typeface="Open Sans" pitchFamily="34" charset="-122"/>
                 <a:cs typeface="Open Sans" pitchFamily="34" charset="-120"/>
               </a:rPr>
-              <a:t>Keine Punkte, keine Noten.</a:t>
+              <a:t>Prototyp-Score, keine Note.</a:t>
             </a:r>
             <a:endParaRPr lang="en-US" sz="1450" dirty="0"/>
           </a:p>
@@ -11244,47 +11283,47 @@
 </file>
 
 <file path=ppt/theme/theme1.xml><?xml version="1.0" encoding="utf-8"?>
-<a:theme xmlns:a="http://schemas.openxmlformats.org/drawingml/2006/main" name="418 Pitch Practice">
+<a:theme xmlns:a="http://schemas.openxmlformats.org/drawingml/2006/main" name="Office Theme">
   <a:themeElements>
-    <a:clrScheme name="418 Pitch Practice">
+    <a:clrScheme name="Office">
       <a:dk1>
-        <a:srgbClr val="17111F"/>
+        <a:sysClr val="windowText" lastClr="000000"/>
       </a:dk1>
       <a:lt1>
-        <a:srgbClr val="FFFFFF"/>
+        <a:sysClr val="window" lastClr="FFFFFF"/>
       </a:lt1>
       <a:dk2>
-        <a:srgbClr val="6B6577"/>
+        <a:srgbClr val="44546A"/>
       </a:dk2>
       <a:lt2>
-        <a:srgbClr val="F4F0FC"/>
+        <a:srgbClr val="E7E6E6"/>
       </a:lt2>
       <a:accent1>
-        <a:srgbClr val="3803BF"/>
+        <a:srgbClr val="4472C4"/>
       </a:accent1>
       <a:accent2>
-        <a:srgbClr val="6C3CE0"/>
+        <a:srgbClr val="ED7D31"/>
       </a:accent2>
       <a:accent3>
-        <a:srgbClr val="CBB6F6"/>
+        <a:srgbClr val="A5A5A5"/>
       </a:accent3>
       <a:accent4>
-        <a:srgbClr val="150826"/>
+        <a:srgbClr val="FFC000"/>
       </a:accent4>
       <a:accent5>
-        <a:srgbClr val="E7DEF8"/>
+        <a:srgbClr val="5B9BD5"/>
       </a:accent5>
       <a:accent6>
-        <a:srgbClr val="8E82B8"/>
+        <a:srgbClr val="70AD47"/>
       </a:accent6>
       <a:hlink>
-        <a:srgbClr val="3803BF"/>
+        <a:srgbClr val="0563C1"/>
       </a:hlink>
       <a:folHlink>
-        <a:srgbClr val="3803BF"/>
+        <a:srgbClr val="954F72"/>
       </a:folHlink>
     </a:clrScheme>
-    <a:fontScheme name="418 Pitch Practice">
+    <a:fontScheme name="Office">
       <a:majorFont>
         <a:latin typeface="Open Sans"/>
         <a:ea typeface=""/>

</xml_diff>

<commit_message>
Preserve stopped takes and remove audited legacy code
</commit_message>
<xml_diff>
--- a/pitch/PitchPractice-Pitch.pptx
+++ b/pitch/PitchPractice-Pitch.pptx
@@ -120,23 +120,23 @@
   <p:extLst>
     <p:ext uri="{521415D9-36F7-43E2-AB2F-B90AF26B5E84}">
       <p14:sectionLst xmlns:p14="http://schemas.microsoft.com/office/powerpoint/2010/main">
-        <p14:section name="Auftakt" id="{7b05788e-6e65-e7fe-f867-2b0357919c6b}">
+        <p14:section name="Auftakt" id="{a2ddb88b-1a05-6fff-e6ff-cd8c7f8c09b4}">
           <p14:sldIdLst>
             <p14:sldId id="256"/>
           </p14:sldIdLst>
         </p14:section>
-        <p14:section name="Problem &amp; Lösung" id="{f6f30cc2-e2f8-435b-aa42-5841c42bcab4}">
+        <p14:section name="Problem &amp; Lösung" id="{caf01da3-8655-7a1a-97f8-eca67839370b}">
           <p14:sldIdLst>
             <p14:sldId id="257"/>
             <p14:sldId id="258"/>
           </p14:sldIdLst>
         </p14:section>
-        <p14:section name="Demo" id="{c558c2c7-fd01-a56d-f16a-cb574b9e3da6}">
+        <p14:section name="Demo" id="{5de534fa-263b-bdac-8dc9-3e690c9bb797}">
           <p14:sldIdLst>
             <p14:sldId id="259"/>
           </p14:sldIdLst>
         </p14:section>
-        <p14:section name="Features" id="{e7e10c4c-15f5-c3b2-f9de-b5c74908e65c}">
+        <p14:section name="Features" id="{9713a951-d4f3-82dc-7679-7623907e016f}">
           <p14:sldIdLst>
             <p14:sldId id="260"/>
             <p14:sldId id="261"/>
@@ -145,14 +145,14 @@
             <p14:sldId id="264"/>
           </p14:sldIdLst>
         </p14:section>
-        <p14:section name="Technik &amp; Zahlen" id="{b9f59b67-00b4-62df-cfdf-1e76ed9da422}">
+        <p14:section name="Technik &amp; Zahlen" id="{17bc079b-251b-f1c2-6366-3aea8f9a60e1}">
           <p14:sldIdLst>
             <p14:sldId id="265"/>
             <p14:sldId id="266"/>
             <p14:sldId id="267"/>
           </p14:sldIdLst>
         </p14:section>
-        <p14:section name="Reflection &amp; Abschluss" id="{5293656e-721a-efd9-0f01-8af7581983d9}">
+        <p14:section name="Reflection &amp; Abschluss" id="{a9a09929-f22b-76ab-05c1-ba2355543c0e}">
           <p14:sldIdLst>
             <p14:sldId id="268"/>
             <p14:sldId id="269"/>
@@ -738,7 +738,7 @@
           <a:p>
             <a:r>
               <a:rPr lang="en-US" dirty="0"/>
-              <a:t>Datenschutz war für uns ein Feature, kein Anhängsel. Das Video verlässt den Client nie, das Original-Audio wird nach der Analyse gelöscht — auch bei Fehlern —, Pose-Frames gehen zu keinem Anbieter. Heuristiken kennzeichnen wir offen als unvalidiert. Die Auswertung zeigt evidenzbasierte Prototyp-Scores, aber keine Noten und keine Emotionsanalyse.</a:t>
+              <a:t>Datenschutz war für uns ein Feature, kein Anhängsel. Das Review spielt die lokale Aufnahme ab. Der vollständige Aufnahme-Container geht temporär an den Analyse-Server und wird nach terminaler Verarbeitung gelöscht; bei Speicherfehlern wird die Löschung erneut versucht. Pose-Frames gehen zu keinem Anbieter. Optionales Deepgram-Streaming sendet Audio nach Einwilligung an Deepgram EU. Heuristiken kennzeichnen wir offen als unvalidiert. Die Auswertung zeigt evidenzbasierte Prototyp-Scores, aber keine Noten und keine Emotionsanalyse.</a:t>
             </a:r>
             <a:endParaRPr lang="en-US" dirty="0"/>
           </a:p>
@@ -1442,7 +1442,7 @@
           <a:p>
             <a:r>
               <a:rPr lang="en-US" dirty="0"/>
-              <a:t>Die Transkription läuft lokal mit faster-whisper, mit Wort-Timestamps. Das Audio verlässt den Browser nur zum lokalen Server und wird nach der Analyse gelöscht. Der Fact-Check läuft in vier Schritten: Aussagen extrahieren, Quellen per Hybrid-Suche durchsuchen, Urteil mit wörtlichem Zitat — und der Code prüft per String-Match, dass das Zitat wirklich in der Quelle steht. Und wichtig: „Nicht gefunden“ ist nicht „falsch“.</a:t>
+              <a:t>Die Transkription läuft lokal mit faster-whisper, mit Wort-Timestamps. Die Aufnahme wird temporär zum lokalen Server hochgeladen und nach der Analyse gelöscht. Optionales Deepgram-Live-Streaming sendet Audio nach Einwilligung an Deepgram EU. Der Fact-Check läuft in vier Schritten: Aussagen extrahieren, Quellen per Hybrid-Suche durchsuchen, Urteil mit wörtlichem Zitat — und der Code prüft per String-Match, dass das Zitat wirklich in der Quelle steht. Und wichtig: „Nicht gefunden“ ist nicht „falsch“.</a:t>
             </a:r>
             <a:endParaRPr lang="en-US" dirty="0"/>
           </a:p>
@@ -1618,7 +1618,7 @@
           <a:p>
             <a:r>
               <a:rPr lang="en-US" dirty="0"/>
-              <a:t>Das Herzstück für den Wert in unter drei Minuten: eine gemeinsame Timeline. Ein Klick auf einen Marker springt per Peak-Zeitstempel zur Stelle im lokalen Video, plus minus zwei Sekunden. Es gibt bewusst keinen serverseitigen Clip — das Video bleibt beim Nutzer. Dazu kommen evidenzbasierte Kriterien-Scores; Formel und Datenabdeckung stehen direkt im UI. Optional zeigt der Fortschritt eine Messreihe über mehrere Takes, ohne Gesamtscore.</a:t>
+              <a:t>Das Herzstück für den Wert in unter drei Minuten: eine gemeinsame Timeline. Ein Klick auf einen Marker springt per Peak-Zeitstempel zur Stelle im lokalen Video, plus minus zwei Sekunden. Die Wiedergabe nutzt das lokale Video. Der vollständige Aufnahme-Container wird temporär zur Analyse hochgeladen; es gibt keinen serverseitigen Review-Clip. Dazu kommen evidenzbasierte Kriterien-Scores; Formel und Datenabdeckung stehen direkt im UI. Optional zeigt der Fortschritt eine Messreihe über mehrere Takes, ohne Gesamtscore.</a:t>
             </a:r>
             <a:endParaRPr lang="en-US" dirty="0"/>
           </a:p>
@@ -2297,7 +2297,7 @@
       </p:sp>
       <p:pic>
         <p:nvPicPr>
-          <p:cNvPr id="3" name="Image 0" descr="C:\Users\Johannes\miniprojects\hackatron\frontend\public\brand\418-pitch-practice.png">    </p:cNvPr>
+          <p:cNvPr id="3" name="Image 0" descr="/private/tmp/fulda-audit-cleanup/frontend/public/brand/418-pitch-practice.png">    </p:cNvPr>
           <p:cNvPicPr>
             <a:picLocks noChangeAspect="1"/>
           </p:cNvPicPr>
@@ -3215,7 +3215,7 @@
                 <a:ea typeface="Open Sans" pitchFamily="34" charset="-122"/>
                 <a:cs typeface="Open Sans" pitchFamily="34" charset="-120"/>
               </a:rPr>
-              <a:t>Video bleibt beim Client</a:t>
+              <a:t>Wiedergabe bleibt lokal</a:t>
             </a:r>
             <a:endParaRPr lang="en-US" sz="1350" dirty="0"/>
           </a:p>
@@ -3254,7 +3254,7 @@
                 <a:ea typeface="Open Sans" pitchFamily="34" charset="-122"/>
                 <a:cs typeface="Open Sans" pitchFamily="34" charset="-120"/>
               </a:rPr>
-              <a:t>keine Server-Clips, keine Snapshots</a:t>
+              <a:t>Aufnahme temporär zur Server-Analyse</a:t>
             </a:r>
             <a:endParaRPr lang="en-US" sz="1200" dirty="0"/>
           </a:p>
@@ -5529,7 +5529,7 @@
       </p:sp>
       <p:pic>
         <p:nvPicPr>
-          <p:cNvPr id="3" name="Image 0" descr="C:\Users\Johannes\miniprojects\hackatron\frontend\public\brand\418-pitch-practice.png">    </p:cNvPr>
+          <p:cNvPr id="3" name="Image 0" descr="/private/tmp/fulda-audit-cleanup/frontend/public/brand/418-pitch-practice.png">    </p:cNvPr>
           <p:cNvPicPr>
             <a:picLocks noChangeAspect="1"/>
           </p:cNvPicPr>
@@ -5623,7 +5623,7 @@
                 <a:ea typeface="Open Sans" pitchFamily="34" charset="-122"/>
                 <a:cs typeface="Open Sans" pitchFamily="34" charset="-120"/>
               </a:rPr>
-              <a:t>Prototyp läuft lokal: localhost:3000 — kein Login; Cloud nur für Quellencheck und Fragen.</a:t>
+              <a:t>Prototyp läuft lokal: localhost:3000 — kein Login; Cloud: Quellencheck, Fragen und optional Live-ASR.</a:t>
             </a:r>
             <a:endParaRPr lang="en-US" sz="1800" dirty="0"/>
           </a:p>
@@ -10511,7 +10511,7 @@
                 <a:ea typeface="Open Sans" pitchFamily="34" charset="-122"/>
                 <a:cs typeface="Open Sans" pitchFamily="34" charset="-120"/>
               </a:rPr>
-              <a:t>Kein serverseitiger Clip — das Video bleibt beim Nutzer.</a:t>
+              <a:t>Lokale Wiedergabe; Aufnahme temporär zur Analyse am Server.</a:t>
             </a:r>
             <a:endParaRPr lang="en-US" sz="1450" dirty="0"/>
           </a:p>

</xml_diff>

<commit_message>
Finish audit cleanup for voice-only review and pitch artifacts
</commit_message>
<xml_diff>
--- a/pitch/PitchPractice-Pitch.pptx
+++ b/pitch/PitchPractice-Pitch.pptx
@@ -120,23 +120,23 @@
   <p:extLst>
     <p:ext uri="{521415D9-36F7-43E2-AB2F-B90AF26B5E84}">
       <p14:sectionLst xmlns:p14="http://schemas.microsoft.com/office/powerpoint/2010/main">
-        <p14:section name="Auftakt" id="{a2ddb88b-1a05-6fff-e6ff-cd8c7f8c09b4}">
+        <p14:section name="Auftakt" id="{a8fcbc98-a50e-c9f5-f656-e1746cef1b9b}">
           <p14:sldIdLst>
             <p14:sldId id="256"/>
           </p14:sldIdLst>
         </p14:section>
-        <p14:section name="Problem &amp; Lösung" id="{caf01da3-8655-7a1a-97f8-eca67839370b}">
+        <p14:section name="Problem &amp; Lösung" id="{e26b4483-47df-616c-61d1-391e7d790dc3}">
           <p14:sldIdLst>
             <p14:sldId id="257"/>
             <p14:sldId id="258"/>
           </p14:sldIdLst>
         </p14:section>
-        <p14:section name="Demo" id="{5de534fa-263b-bdac-8dc9-3e690c9bb797}">
+        <p14:section name="Demo" id="{fae78812-823d-a696-9574-0cf11e83c5c4}">
           <p14:sldIdLst>
             <p14:sldId id="259"/>
           </p14:sldIdLst>
         </p14:section>
-        <p14:section name="Features" id="{9713a951-d4f3-82dc-7679-7623907e016f}">
+        <p14:section name="Features" id="{bf78bd9a-6bca-5706-6681-19f40f19c6b6}">
           <p14:sldIdLst>
             <p14:sldId id="260"/>
             <p14:sldId id="261"/>
@@ -145,14 +145,14 @@
             <p14:sldId id="264"/>
           </p14:sldIdLst>
         </p14:section>
-        <p14:section name="Technik &amp; Zahlen" id="{17bc079b-251b-f1c2-6366-3aea8f9a60e1}">
+        <p14:section name="Technik &amp; Zahlen" id="{09c77c1f-d23f-3be2-8d29-f741565e4a60}">
           <p14:sldIdLst>
             <p14:sldId id="265"/>
             <p14:sldId id="266"/>
             <p14:sldId id="267"/>
           </p14:sldIdLst>
         </p14:section>
-        <p14:section name="Reflection &amp; Abschluss" id="{a9a09929-f22b-76ab-05c1-ba2355543c0e}">
+        <p14:section name="Reflection &amp; Abschluss" id="{e83a6f47-f8ca-7a7f-9d1c-a7ef9cb98cbb}">
           <p14:sldIdLst>
             <p14:sldId id="268"/>
             <p14:sldId id="269"/>
@@ -1706,7 +1706,7 @@
           <a:p>
             <a:r>
               <a:rPr lang="en-US" dirty="0"/>
-              <a:t>Nach dem Vortrag übernimmt der Frage-Agent. Er fragt gezielt nach Widersprüchen und Lücken aus dem Fact-Check, Antworten können getippt oder gesprochen werden, und jede Antwort wird mit Zitat-Prüfung gegen die Quellen verglichen. Zwei Rollen sind wählbar: neugieriges Erstsemester oder kritischer Professor. Die Auswertung nach der getippten Runde ist ein transparenter Prototyp-Score aus gemessenen Urteilen, keine Note.</a:t>
+              <a:t>Nach dem Vortrag übernimmt der ElevenLabs-Sprachagent. Er nutzt Transkript, Quellen und Fact-Check-Funde als Kontext. Zwei Rollen sind wählbar: neugieriges Erstsemester oder kritischer Professor. Die Sprachreaktionen sind nicht zitateverifiziert und liefern keine geprüften Antwort-Urteile für den Score. Die Auswertung nutzt die gemessene Evidenz der Aufnahme, keine Note. Der frühere getippte Fragepfad bleibt nur als Backend-Schnittstelle und für gespeicherte Antworten erhalten.</a:t>
             </a:r>
             <a:endParaRPr lang="en-US" dirty="0"/>
           </a:p>
@@ -1870,6 +1870,48 @@
               <a:t>418 presentation studio</a:t>
             </a:r>
             <a:endParaRPr lang="en-US" sz="900" dirty="0"/>
+          </a:p>
+        </p:txBody>
+      </p:sp>
+      <p:sp>
+        <p:nvSpPr>
+          <p:cNvPr id="3" name="Text 1"/>
+          <p:cNvSpPr/>
+          <p:nvPr>
+            <p:ph idx="101" type="title" hasCustomPrompt="1"/>
+          </p:nvPr>
+        </p:nvSpPr>
+        <p:spPr>
+          <a:xfrm>
+            <a:off x="566928" y="402336"/>
+            <a:ext cx="11064240" cy="868680"/>
+          </a:xfrm>
+          <a:prstGeom prst="rect">
+            <a:avLst/>
+          </a:prstGeom>
+          <a:noFill/>
+          <a:ln/>
+        </p:spPr>
+        <p:txBody>
+          <a:bodyPr wrap="square" rtlCol="0"/>
+          <a:lstStyle>
+            <a:lvl1pPr indent="0" marL="0">
+              <a:buNone/>
+              <a:defRPr lang="en-US" sz="3000" b="1" dirty="0">
+                <a:solidFill>
+                  <a:srgbClr val="17111F"/>
+                </a:solidFill>
+                <a:latin typeface="Open Sans" pitchFamily="34" charset="0"/>
+                <a:ea typeface="Open Sans" pitchFamily="34" charset="-122"/>
+                <a:cs typeface="Open Sans" pitchFamily="34" charset="-120"/>
+              </a:defRPr>
+            </a:lvl1pPr>
+          </a:lstStyle>
+          <a:p>
+            <a:pPr indent="0" marL="0">
+              <a:buNone/>
+            </a:pPr>
+            <a:endParaRPr lang="en-US" sz="3000" dirty="0"/>
           </a:p>
         </p:txBody>
       </p:sp>
@@ -2502,33 +2544,42 @@
       </p:grpSpPr>
       <p:sp>
         <p:nvSpPr>
-          <p:cNvPr id="2" name="Text 0"/>
+          <p:cNvPr id="2" name="Text 1"/>
           <p:cNvSpPr/>
-          <p:nvPr/>
-        </p:nvSpPr>
-        <p:spPr>
-          <a:xfrm>
-            <a:off x="0" y="0"/>
-            <a:ext cx="9143771" cy="0"/>
-          </a:xfrm>
-          <a:prstGeom prst="rect">
-            <a:avLst/>
-          </a:prstGeom>
-          <a:noFill/>
-          <a:ln/>
-        </p:spPr>
-        <p:txBody>
-          <a:bodyPr wrap="square" rtlCol="0"/>
+          <p:nvPr>
+            <p:ph idx="101" type="title" hasCustomPrompt="1"/>
+          </p:nvPr>
+        </p:nvSpPr>
+        <p:spPr>
+          <a:xfrm>
+            <a:off x="566928" y="402336"/>
+            <a:ext cx="11064240" cy="868680"/>
+          </a:xfrm>
+          <a:prstGeom prst="rect">
+            <a:avLst/>
+          </a:prstGeom>
+          <a:noFill/>
+          <a:ln/>
+        </p:spPr>
+        <p:txBody>
+          <a:bodyPr wrap="square" lIns="0" tIns="0" rIns="0" bIns="0" rtlCol="0"/>
           <a:lstStyle/>
           <a:p>
             <a:pPr indent="0" marL="0">
               <a:buNone/>
             </a:pPr>
             <a:r>
-              <a:rPr lang="en-US" dirty="0"/>
+              <a:rPr lang="en-US" sz="3000" b="1" dirty="0">
+                <a:solidFill>
+                  <a:srgbClr val="17111F"/>
+                </a:solidFill>
+                <a:latin typeface="Open Sans" pitchFamily="34" charset="0"/>
+                <a:ea typeface="Open Sans" pitchFamily="34" charset="-122"/>
+                <a:cs typeface="Open Sans" pitchFamily="34" charset="-120"/>
+              </a:rPr>
               <a:t>Ein Befehl — lokaler Standard, Cloud optional</a:t>
             </a:r>
-            <a:endParaRPr lang="en-US" dirty="0"/>
+            <a:endParaRPr lang="en-US" sz="3000" dirty="0"/>
           </a:p>
         </p:txBody>
       </p:sp>
@@ -3086,33 +3137,42 @@
       </p:grpSpPr>
       <p:sp>
         <p:nvSpPr>
-          <p:cNvPr id="2" name="Text 0"/>
+          <p:cNvPr id="2" name="Text 1"/>
           <p:cNvSpPr/>
-          <p:nvPr/>
-        </p:nvSpPr>
-        <p:spPr>
-          <a:xfrm>
-            <a:off x="0" y="0"/>
-            <a:ext cx="9143771" cy="0"/>
-          </a:xfrm>
-          <a:prstGeom prst="rect">
-            <a:avLst/>
-          </a:prstGeom>
-          <a:noFill/>
-          <a:ln/>
-        </p:spPr>
-        <p:txBody>
-          <a:bodyPr wrap="square" rtlCol="0"/>
+          <p:nvPr>
+            <p:ph idx="101" type="title" hasCustomPrompt="1"/>
+          </p:nvPr>
+        </p:nvSpPr>
+        <p:spPr>
+          <a:xfrm>
+            <a:off x="566928" y="402336"/>
+            <a:ext cx="11064240" cy="868680"/>
+          </a:xfrm>
+          <a:prstGeom prst="rect">
+            <a:avLst/>
+          </a:prstGeom>
+          <a:noFill/>
+          <a:ln/>
+        </p:spPr>
+        <p:txBody>
+          <a:bodyPr wrap="square" lIns="0" tIns="0" rIns="0" bIns="0" rtlCol="0"/>
           <a:lstStyle/>
           <a:p>
             <a:pPr indent="0" marL="0">
               <a:buNone/>
             </a:pPr>
             <a:r>
-              <a:rPr lang="en-US" dirty="0"/>
+              <a:rPr lang="en-US" sz="3000" b="1" dirty="0">
+                <a:solidFill>
+                  <a:srgbClr val="17111F"/>
+                </a:solidFill>
+                <a:latin typeface="Open Sans" pitchFamily="34" charset="0"/>
+                <a:ea typeface="Open Sans" pitchFamily="34" charset="-122"/>
+                <a:cs typeface="Open Sans" pitchFamily="34" charset="-120"/>
+              </a:rPr>
               <a:t>Privat by design — ehrlich by design</a:t>
             </a:r>
-            <a:endParaRPr lang="en-US" dirty="0"/>
+            <a:endParaRPr lang="en-US" sz="3000" dirty="0"/>
           </a:p>
         </p:txBody>
       </p:sp>
@@ -4094,33 +4154,42 @@
       </p:grpSpPr>
       <p:sp>
         <p:nvSpPr>
-          <p:cNvPr id="2" name="Text 0"/>
+          <p:cNvPr id="2" name="Text 1"/>
           <p:cNvSpPr/>
-          <p:nvPr/>
-        </p:nvSpPr>
-        <p:spPr>
-          <a:xfrm>
-            <a:off x="0" y="0"/>
-            <a:ext cx="9143771" cy="0"/>
-          </a:xfrm>
-          <a:prstGeom prst="rect">
-            <a:avLst/>
-          </a:prstGeom>
-          <a:noFill/>
-          <a:ln/>
-        </p:spPr>
-        <p:txBody>
-          <a:bodyPr wrap="square" rtlCol="0"/>
+          <p:nvPr>
+            <p:ph idx="101" type="title" hasCustomPrompt="1"/>
+          </p:nvPr>
+        </p:nvSpPr>
+        <p:spPr>
+          <a:xfrm>
+            <a:off x="566928" y="402336"/>
+            <a:ext cx="11064240" cy="868680"/>
+          </a:xfrm>
+          <a:prstGeom prst="rect">
+            <a:avLst/>
+          </a:prstGeom>
+          <a:noFill/>
+          <a:ln/>
+        </p:spPr>
+        <p:txBody>
+          <a:bodyPr wrap="square" lIns="0" tIns="0" rIns="0" bIns="0" rtlCol="0"/>
           <a:lstStyle/>
           <a:p>
             <a:pPr indent="0" marL="0">
               <a:buNone/>
             </a:pPr>
             <a:r>
-              <a:rPr lang="en-US" dirty="0"/>
+              <a:rPr lang="en-US" sz="3000" b="1" dirty="0">
+                <a:solidFill>
+                  <a:srgbClr val="17111F"/>
+                </a:solidFill>
+                <a:latin typeface="Open Sans" pitchFamily="34" charset="0"/>
+                <a:ea typeface="Open Sans" pitchFamily="34" charset="-122"/>
+                <a:cs typeface="Open Sans" pitchFamily="34" charset="-120"/>
+              </a:rPr>
               <a:t>Gemessen im Prototyp — nicht versprochen</a:t>
             </a:r>
-            <a:endParaRPr lang="en-US" dirty="0"/>
+            <a:endParaRPr lang="en-US" sz="3000" dirty="0"/>
           </a:p>
         </p:txBody>
       </p:sp>
@@ -5734,33 +5803,42 @@
       </p:grpSpPr>
       <p:sp>
         <p:nvSpPr>
-          <p:cNvPr id="2" name="Text 0"/>
+          <p:cNvPr id="2" name="Text 1"/>
           <p:cNvSpPr/>
-          <p:nvPr/>
-        </p:nvSpPr>
-        <p:spPr>
-          <a:xfrm>
-            <a:off x="0" y="0"/>
-            <a:ext cx="9143771" cy="0"/>
-          </a:xfrm>
-          <a:prstGeom prst="rect">
-            <a:avLst/>
-          </a:prstGeom>
-          <a:noFill/>
-          <a:ln/>
-        </p:spPr>
-        <p:txBody>
-          <a:bodyPr wrap="square" rtlCol="0"/>
+          <p:nvPr>
+            <p:ph idx="101" type="title" hasCustomPrompt="1"/>
+          </p:nvPr>
+        </p:nvSpPr>
+        <p:spPr>
+          <a:xfrm>
+            <a:off x="566928" y="402336"/>
+            <a:ext cx="11064240" cy="868680"/>
+          </a:xfrm>
+          <a:prstGeom prst="rect">
+            <a:avLst/>
+          </a:prstGeom>
+          <a:noFill/>
+          <a:ln/>
+        </p:spPr>
+        <p:txBody>
+          <a:bodyPr wrap="square" lIns="0" tIns="0" rIns="0" bIns="0" rtlCol="0"/>
           <a:lstStyle/>
           <a:p>
             <a:pPr indent="0" marL="0">
               <a:buNone/>
             </a:pPr>
             <a:r>
-              <a:rPr lang="en-US" dirty="0"/>
+              <a:rPr lang="en-US" sz="3000" b="1" dirty="0">
+                <a:solidFill>
+                  <a:srgbClr val="17111F"/>
+                </a:solidFill>
+                <a:latin typeface="Open Sans" pitchFamily="34" charset="0"/>
+                <a:ea typeface="Open Sans" pitchFamily="34" charset="-122"/>
+                <a:cs typeface="Open Sans" pitchFamily="34" charset="-120"/>
+              </a:rPr>
               <a:t>Üben allein macht nicht besser</a:t>
             </a:r>
-            <a:endParaRPr lang="en-US" dirty="0"/>
+            <a:endParaRPr lang="en-US" sz="3000" dirty="0"/>
           </a:p>
         </p:txBody>
       </p:sp>
@@ -6851,33 +6929,42 @@
       </p:grpSpPr>
       <p:sp>
         <p:nvSpPr>
-          <p:cNvPr id="2" name="Text 0"/>
+          <p:cNvPr id="2" name="Text 1"/>
           <p:cNvSpPr/>
-          <p:nvPr/>
-        </p:nvSpPr>
-        <p:spPr>
-          <a:xfrm>
-            <a:off x="0" y="0"/>
-            <a:ext cx="9143771" cy="0"/>
-          </a:xfrm>
-          <a:prstGeom prst="rect">
-            <a:avLst/>
-          </a:prstGeom>
-          <a:noFill/>
-          <a:ln/>
-        </p:spPr>
-        <p:txBody>
-          <a:bodyPr wrap="square" rtlCol="0"/>
+          <p:nvPr>
+            <p:ph idx="101" type="title" hasCustomPrompt="1"/>
+          </p:nvPr>
+        </p:nvSpPr>
+        <p:spPr>
+          <a:xfrm>
+            <a:off x="566928" y="402336"/>
+            <a:ext cx="11064240" cy="868680"/>
+          </a:xfrm>
+          <a:prstGeom prst="rect">
+            <a:avLst/>
+          </a:prstGeom>
+          <a:noFill/>
+          <a:ln/>
+        </p:spPr>
+        <p:txBody>
+          <a:bodyPr wrap="square" lIns="0" tIns="0" rIns="0" bIns="0" rtlCol="0"/>
           <a:lstStyle/>
           <a:p>
             <a:pPr indent="0" marL="0">
               <a:buNone/>
             </a:pPr>
             <a:r>
-              <a:rPr lang="en-US" dirty="0"/>
+              <a:rPr lang="en-US" sz="3000" b="1" dirty="0">
+                <a:solidFill>
+                  <a:srgbClr val="17111F"/>
+                </a:solidFill>
+                <a:latin typeface="Open Sans" pitchFamily="34" charset="0"/>
+                <a:ea typeface="Open Sans" pitchFamily="34" charset="-122"/>
+                <a:cs typeface="Open Sans" pitchFamily="34" charset="-120"/>
+              </a:rPr>
               <a:t>Live-Demo</a:t>
             </a:r>
-            <a:endParaRPr lang="en-US" dirty="0"/>
+            <a:endParaRPr lang="en-US" sz="3000" dirty="0"/>
           </a:p>
         </p:txBody>
       </p:sp>
@@ -7544,33 +7631,42 @@
       </p:grpSpPr>
       <p:sp>
         <p:nvSpPr>
-          <p:cNvPr id="2" name="Text 0"/>
+          <p:cNvPr id="2" name="Text 1"/>
           <p:cNvSpPr/>
-          <p:nvPr/>
-        </p:nvSpPr>
-        <p:spPr>
-          <a:xfrm>
-            <a:off x="0" y="0"/>
-            <a:ext cx="9143771" cy="0"/>
-          </a:xfrm>
-          <a:prstGeom prst="rect">
-            <a:avLst/>
-          </a:prstGeom>
-          <a:noFill/>
-          <a:ln/>
-        </p:spPr>
-        <p:txBody>
-          <a:bodyPr wrap="square" rtlCol="0"/>
+          <p:nvPr>
+            <p:ph idx="101" type="title" hasCustomPrompt="1"/>
+          </p:nvPr>
+        </p:nvSpPr>
+        <p:spPr>
+          <a:xfrm>
+            <a:off x="566928" y="402336"/>
+            <a:ext cx="11064240" cy="868680"/>
+          </a:xfrm>
+          <a:prstGeom prst="rect">
+            <a:avLst/>
+          </a:prstGeom>
+          <a:noFill/>
+          <a:ln/>
+        </p:spPr>
+        <p:txBody>
+          <a:bodyPr wrap="square" lIns="0" tIns="0" rIns="0" bIns="0" rtlCol="0"/>
           <a:lstStyle/>
           <a:p>
             <a:pPr indent="0" marL="0">
               <a:buNone/>
             </a:pPr>
             <a:r>
-              <a:rPr lang="en-US" dirty="0"/>
+              <a:rPr lang="en-US" sz="3000" b="1" dirty="0">
+                <a:solidFill>
+                  <a:srgbClr val="17111F"/>
+                </a:solidFill>
+                <a:latin typeface="Open Sans" pitchFamily="34" charset="0"/>
+                <a:ea typeface="Open Sans" pitchFamily="34" charset="-122"/>
+                <a:cs typeface="Open Sans" pitchFamily="34" charset="-120"/>
+              </a:rPr>
               <a:t>Pose &amp; Gestik — komplett im Browser</a:t>
             </a:r>
-            <a:endParaRPr lang="en-US" dirty="0"/>
+            <a:endParaRPr lang="en-US" sz="3000" dirty="0"/>
           </a:p>
         </p:txBody>
       </p:sp>
@@ -8268,33 +8364,42 @@
       </p:grpSpPr>
       <p:sp>
         <p:nvSpPr>
-          <p:cNvPr id="2" name="Text 0"/>
+          <p:cNvPr id="2" name="Text 1"/>
           <p:cNvSpPr/>
-          <p:nvPr/>
-        </p:nvSpPr>
-        <p:spPr>
-          <a:xfrm>
-            <a:off x="0" y="0"/>
-            <a:ext cx="9143771" cy="0"/>
-          </a:xfrm>
-          <a:prstGeom prst="rect">
-            <a:avLst/>
-          </a:prstGeom>
-          <a:noFill/>
-          <a:ln/>
-        </p:spPr>
-        <p:txBody>
-          <a:bodyPr wrap="square" rtlCol="0"/>
+          <p:nvPr>
+            <p:ph idx="101" type="title" hasCustomPrompt="1"/>
+          </p:nvPr>
+        </p:nvSpPr>
+        <p:spPr>
+          <a:xfrm>
+            <a:off x="566928" y="402336"/>
+            <a:ext cx="11064240" cy="868680"/>
+          </a:xfrm>
+          <a:prstGeom prst="rect">
+            <a:avLst/>
+          </a:prstGeom>
+          <a:noFill/>
+          <a:ln/>
+        </p:spPr>
+        <p:txBody>
+          <a:bodyPr wrap="square" lIns="0" tIns="0" rIns="0" bIns="0" rtlCol="0"/>
           <a:lstStyle/>
           <a:p>
             <a:pPr indent="0" marL="0">
               <a:buNone/>
             </a:pPr>
             <a:r>
-              <a:rPr lang="en-US" dirty="0"/>
+              <a:rPr lang="en-US" sz="3000" b="1" dirty="0">
+                <a:solidFill>
+                  <a:srgbClr val="17111F"/>
+                </a:solidFill>
+                <a:latin typeface="Open Sans" pitchFamily="34" charset="0"/>
+                <a:ea typeface="Open Sans" pitchFamily="34" charset="-122"/>
+                <a:cs typeface="Open Sans" pitchFamily="34" charset="-120"/>
+              </a:rPr>
               <a:t>Transkript &amp; zitiergenauer Fact-Check</a:t>
             </a:r>
-            <a:endParaRPr lang="en-US" dirty="0"/>
+            <a:endParaRPr lang="en-US" sz="3000" dirty="0"/>
           </a:p>
         </p:txBody>
       </p:sp>
@@ -9059,33 +9164,42 @@
       </p:grpSpPr>
       <p:sp>
         <p:nvSpPr>
-          <p:cNvPr id="2" name="Text 0"/>
+          <p:cNvPr id="2" name="Text 1"/>
           <p:cNvSpPr/>
-          <p:nvPr/>
-        </p:nvSpPr>
-        <p:spPr>
-          <a:xfrm>
-            <a:off x="0" y="0"/>
-            <a:ext cx="9143771" cy="0"/>
-          </a:xfrm>
-          <a:prstGeom prst="rect">
-            <a:avLst/>
-          </a:prstGeom>
-          <a:noFill/>
-          <a:ln/>
-        </p:spPr>
-        <p:txBody>
-          <a:bodyPr wrap="square" rtlCol="0"/>
+          <p:nvPr>
+            <p:ph idx="101" type="title" hasCustomPrompt="1"/>
+          </p:nvPr>
+        </p:nvSpPr>
+        <p:spPr>
+          <a:xfrm>
+            <a:off x="566928" y="402336"/>
+            <a:ext cx="11064240" cy="868680"/>
+          </a:xfrm>
+          <a:prstGeom prst="rect">
+            <a:avLst/>
+          </a:prstGeom>
+          <a:noFill/>
+          <a:ln/>
+        </p:spPr>
+        <p:txBody>
+          <a:bodyPr wrap="square" lIns="0" tIns="0" rIns="0" bIns="0" rtlCol="0"/>
           <a:lstStyle/>
           <a:p>
             <a:pPr indent="0" marL="0">
               <a:buNone/>
             </a:pPr>
             <a:r>
-              <a:rPr lang="en-US" dirty="0"/>
+              <a:rPr lang="en-US" sz="3000" b="1" dirty="0">
+                <a:solidFill>
+                  <a:srgbClr val="17111F"/>
+                </a:solidFill>
+                <a:latin typeface="Open Sans" pitchFamily="34" charset="0"/>
+                <a:ea typeface="Open Sans" pitchFamily="34" charset="-122"/>
+                <a:cs typeface="Open Sans" pitchFamily="34" charset="-120"/>
+              </a:rPr>
               <a:t>Stimme: fünf Merkmale, live</a:t>
             </a:r>
-            <a:endParaRPr lang="en-US" dirty="0"/>
+            <a:endParaRPr lang="en-US" sz="3000" dirty="0"/>
           </a:p>
         </p:txBody>
       </p:sp>
@@ -9923,33 +10037,42 @@
       </p:grpSpPr>
       <p:sp>
         <p:nvSpPr>
-          <p:cNvPr id="2" name="Text 0"/>
+          <p:cNvPr id="2" name="Text 1"/>
           <p:cNvSpPr/>
-          <p:nvPr/>
-        </p:nvSpPr>
-        <p:spPr>
-          <a:xfrm>
-            <a:off x="0" y="0"/>
-            <a:ext cx="9143771" cy="0"/>
-          </a:xfrm>
-          <a:prstGeom prst="rect">
-            <a:avLst/>
-          </a:prstGeom>
-          <a:noFill/>
-          <a:ln/>
-        </p:spPr>
-        <p:txBody>
-          <a:bodyPr wrap="square" rtlCol="0"/>
+          <p:nvPr>
+            <p:ph idx="101" type="title" hasCustomPrompt="1"/>
+          </p:nvPr>
+        </p:nvSpPr>
+        <p:spPr>
+          <a:xfrm>
+            <a:off x="566928" y="402336"/>
+            <a:ext cx="11064240" cy="868680"/>
+          </a:xfrm>
+          <a:prstGeom prst="rect">
+            <a:avLst/>
+          </a:prstGeom>
+          <a:noFill/>
+          <a:ln/>
+        </p:spPr>
+        <p:txBody>
+          <a:bodyPr wrap="square" lIns="0" tIns="0" rIns="0" bIns="0" rtlCol="0"/>
           <a:lstStyle/>
           <a:p>
             <a:pPr indent="0" marL="0">
               <a:buNone/>
             </a:pPr>
             <a:r>
-              <a:rPr lang="en-US" dirty="0"/>
+              <a:rPr lang="en-US" sz="3000" b="1" dirty="0">
+                <a:solidFill>
+                  <a:srgbClr val="17111F"/>
+                </a:solidFill>
+                <a:latin typeface="Open Sans" pitchFamily="34" charset="0"/>
+                <a:ea typeface="Open Sans" pitchFamily="34" charset="-122"/>
+                <a:cs typeface="Open Sans" pitchFamily="34" charset="-120"/>
+              </a:rPr>
               <a:t>Review: klicken, zurückspringen, verstehen</a:t>
             </a:r>
-            <a:endParaRPr lang="en-US" dirty="0"/>
+            <a:endParaRPr lang="en-US" sz="3000" dirty="0"/>
           </a:p>
         </p:txBody>
       </p:sp>
@@ -10631,33 +10754,42 @@
       </p:grpSpPr>
       <p:sp>
         <p:nvSpPr>
-          <p:cNvPr id="2" name="Text 0"/>
+          <p:cNvPr id="2" name="Text 1"/>
           <p:cNvSpPr/>
-          <p:nvPr/>
-        </p:nvSpPr>
-        <p:spPr>
-          <a:xfrm>
-            <a:off x="0" y="0"/>
-            <a:ext cx="9143771" cy="0"/>
-          </a:xfrm>
-          <a:prstGeom prst="rect">
-            <a:avLst/>
-          </a:prstGeom>
-          <a:noFill/>
-          <a:ln/>
-        </p:spPr>
-        <p:txBody>
-          <a:bodyPr wrap="square" rtlCol="0"/>
+          <p:nvPr>
+            <p:ph idx="101" type="title" hasCustomPrompt="1"/>
+          </p:nvPr>
+        </p:nvSpPr>
+        <p:spPr>
+          <a:xfrm>
+            <a:off x="566928" y="402336"/>
+            <a:ext cx="11064240" cy="868680"/>
+          </a:xfrm>
+          <a:prstGeom prst="rect">
+            <a:avLst/>
+          </a:prstGeom>
+          <a:noFill/>
+          <a:ln/>
+        </p:spPr>
+        <p:txBody>
+          <a:bodyPr wrap="square" lIns="0" tIns="0" rIns="0" bIns="0" rtlCol="0"/>
           <a:lstStyle/>
           <a:p>
             <a:pPr indent="0" marL="0">
               <a:buNone/>
             </a:pPr>
             <a:r>
-              <a:rPr lang="en-US" dirty="0"/>
+              <a:rPr lang="en-US" sz="3000" b="1" dirty="0">
+                <a:solidFill>
+                  <a:srgbClr val="17111F"/>
+                </a:solidFill>
+                <a:latin typeface="Open Sans" pitchFamily="34" charset="0"/>
+                <a:ea typeface="Open Sans" pitchFamily="34" charset="-122"/>
+                <a:cs typeface="Open Sans" pitchFamily="34" charset="-120"/>
+              </a:rPr>
               <a:t>Danach fragt der Agent</a:t>
             </a:r>
-            <a:endParaRPr lang="en-US" dirty="0"/>
+            <a:endParaRPr lang="en-US" sz="3000" dirty="0"/>
           </a:p>
         </p:txBody>
       </p:sp>
@@ -10904,7 +11036,7 @@
                 <a:ea typeface="Open Sans" pitchFamily="34" charset="-122"/>
                 <a:cs typeface="Open Sans" pitchFamily="34" charset="-120"/>
               </a:rPr>
-              <a:t>Tippen oder sprechen</a:t>
+              <a:t>Fragen im Sprachdialog</a:t>
             </a:r>
             <a:endParaRPr lang="en-US" sz="1550" dirty="0"/>
           </a:p>
@@ -10943,7 +11075,7 @@
                 <a:ea typeface="Open Sans" pitchFamily="34" charset="-122"/>
                 <a:cs typeface="Open Sans" pitchFamily="34" charset="-120"/>
               </a:rPr>
-              <a:t>Voice-Agent liest vor und nimmt auf — optional mit ElevenLabs-Stimme.</a:t>
+              <a:t>ElevenLabs führt das Gespräch — mit Transkript und Quellen als Kontext.</a:t>
             </a:r>
             <a:endParaRPr lang="en-US" sz="1250" dirty="0"/>
           </a:p>
@@ -11048,7 +11180,7 @@
                 <a:ea typeface="Open Sans" pitchFamily="34" charset="-122"/>
                 <a:cs typeface="Open Sans" pitchFamily="34" charset="-120"/>
               </a:rPr>
-              <a:t>Abgleich mit den Quellen</a:t>
+              <a:t>Belege bleiben sichtbar</a:t>
             </a:r>
             <a:endParaRPr lang="en-US" sz="1550" dirty="0"/>
           </a:p>
@@ -11087,7 +11219,7 @@
                 <a:ea typeface="Open Sans" pitchFamily="34" charset="-122"/>
                 <a:cs typeface="Open Sans" pitchFamily="34" charset="-120"/>
               </a:rPr>
-              <a:t>Jede Antwort wird mit Zitat-Prüfung gegen die Unterlagen verglichen.</a:t>
+              <a:t>Der Fact-Check prüft Quellenzitate. Die Sprachreaktionen sind nicht zitateverifiziert.</a:t>
             </a:r>
             <a:endParaRPr lang="en-US" sz="1250" dirty="0"/>
           </a:p>

</xml_diff>